<commit_message>
Content changes complete. Jekyll won't build due to language issues
</commit_message>
<xml_diff>
--- a/input/images/source/framerwork_interactions.pptx
+++ b/input/images/source/framerwork_interactions.pptx
@@ -249,7 +249,7 @@
           <a:p>
             <a:fld id="{8915D0CF-E652-5D47-A697-54CCDB718F90}" type="datetimeFigureOut">
               <a:rPr lang="en-US" smtClean="0"/>
-              <a:t>5/16/19</a:t>
+              <a:t>5/1/2026</a:t>
             </a:fld>
             <a:endParaRPr lang="en-US"/>
           </a:p>
@@ -419,7 +419,7 @@
           <a:p>
             <a:fld id="{8915D0CF-E652-5D47-A697-54CCDB718F90}" type="datetimeFigureOut">
               <a:rPr lang="en-US" smtClean="0"/>
-              <a:t>5/16/19</a:t>
+              <a:t>5/1/2026</a:t>
             </a:fld>
             <a:endParaRPr lang="en-US"/>
           </a:p>
@@ -599,7 +599,7 @@
           <a:p>
             <a:fld id="{8915D0CF-E652-5D47-A697-54CCDB718F90}" type="datetimeFigureOut">
               <a:rPr lang="en-US" smtClean="0"/>
-              <a:t>5/16/19</a:t>
+              <a:t>5/1/2026</a:t>
             </a:fld>
             <a:endParaRPr lang="en-US"/>
           </a:p>
@@ -769,7 +769,7 @@
           <a:p>
             <a:fld id="{8915D0CF-E652-5D47-A697-54CCDB718F90}" type="datetimeFigureOut">
               <a:rPr lang="en-US" smtClean="0"/>
-              <a:t>5/16/19</a:t>
+              <a:t>5/1/2026</a:t>
             </a:fld>
             <a:endParaRPr lang="en-US"/>
           </a:p>
@@ -1015,7 +1015,7 @@
           <a:p>
             <a:fld id="{8915D0CF-E652-5D47-A697-54CCDB718F90}" type="datetimeFigureOut">
               <a:rPr lang="en-US" smtClean="0"/>
-              <a:t>5/16/19</a:t>
+              <a:t>5/1/2026</a:t>
             </a:fld>
             <a:endParaRPr lang="en-US"/>
           </a:p>
@@ -1247,7 +1247,7 @@
           <a:p>
             <a:fld id="{8915D0CF-E652-5D47-A697-54CCDB718F90}" type="datetimeFigureOut">
               <a:rPr lang="en-US" smtClean="0"/>
-              <a:t>5/16/19</a:t>
+              <a:t>5/1/2026</a:t>
             </a:fld>
             <a:endParaRPr lang="en-US"/>
           </a:p>
@@ -1614,7 +1614,7 @@
           <a:p>
             <a:fld id="{8915D0CF-E652-5D47-A697-54CCDB718F90}" type="datetimeFigureOut">
               <a:rPr lang="en-US" smtClean="0"/>
-              <a:t>5/16/19</a:t>
+              <a:t>5/1/2026</a:t>
             </a:fld>
             <a:endParaRPr lang="en-US"/>
           </a:p>
@@ -1732,7 +1732,7 @@
           <a:p>
             <a:fld id="{8915D0CF-E652-5D47-A697-54CCDB718F90}" type="datetimeFigureOut">
               <a:rPr lang="en-US" smtClean="0"/>
-              <a:t>5/16/19</a:t>
+              <a:t>5/1/2026</a:t>
             </a:fld>
             <a:endParaRPr lang="en-US"/>
           </a:p>
@@ -1827,7 +1827,7 @@
           <a:p>
             <a:fld id="{8915D0CF-E652-5D47-A697-54CCDB718F90}" type="datetimeFigureOut">
               <a:rPr lang="en-US" smtClean="0"/>
-              <a:t>5/16/19</a:t>
+              <a:t>5/1/2026</a:t>
             </a:fld>
             <a:endParaRPr lang="en-US"/>
           </a:p>
@@ -2104,7 +2104,7 @@
           <a:p>
             <a:fld id="{8915D0CF-E652-5D47-A697-54CCDB718F90}" type="datetimeFigureOut">
               <a:rPr lang="en-US" smtClean="0"/>
-              <a:t>5/16/19</a:t>
+              <a:t>5/1/2026</a:t>
             </a:fld>
             <a:endParaRPr lang="en-US"/>
           </a:p>
@@ -2361,7 +2361,7 @@
           <a:p>
             <a:fld id="{8915D0CF-E652-5D47-A697-54CCDB718F90}" type="datetimeFigureOut">
               <a:rPr lang="en-US" smtClean="0"/>
-              <a:t>5/16/19</a:t>
+              <a:t>5/1/2026</a:t>
             </a:fld>
             <a:endParaRPr lang="en-US"/>
           </a:p>
@@ -2574,7 +2574,7 @@
           <a:p>
             <a:fld id="{8915D0CF-E652-5D47-A697-54CCDB718F90}" type="datetimeFigureOut">
               <a:rPr lang="en-US" smtClean="0"/>
-              <a:t>5/16/19</a:t>
+              <a:t>5/1/2026</a:t>
             </a:fld>
             <a:endParaRPr lang="en-US"/>
           </a:p>
@@ -3786,7 +3786,7 @@
         </p:nvCxnSpPr>
         <p:spPr>
           <a:xfrm>
-            <a:off x="2512339" y="808291"/>
+            <a:off x="2512339" y="936878"/>
             <a:ext cx="2320684" cy="0"/>
           </a:xfrm>
           <a:prstGeom prst="straightConnector1">
@@ -3825,7 +3825,7 @@
         </p:nvSpPr>
         <p:spPr>
           <a:xfrm>
-            <a:off x="2622466" y="336838"/>
+            <a:off x="2622466" y="567546"/>
             <a:ext cx="1918003" cy="369332"/>
           </a:xfrm>
           <a:prstGeom prst="rect">
@@ -3842,87 +3842,8 @@
             <a:pPr algn="ctr"/>
             <a:r>
               <a:rPr lang="en-US" dirty="0"/>
-              <a:t>Submit CQM Data</a:t>
-            </a:r>
-          </a:p>
-        </p:txBody>
-      </p:sp>
-      <p:cxnSp>
-        <p:nvCxnSpPr>
-          <p:cNvPr id="6" name="Straight Arrow Connector 5">
-            <a:extLst>
-              <a:ext uri="{FF2B5EF4-FFF2-40B4-BE49-F238E27FC236}">
-                <a16:creationId xmlns:a16="http://schemas.microsoft.com/office/drawing/2014/main" id="{E139EF16-53B7-E144-9F8F-2BA3DB3D4F1D}"/>
-              </a:ext>
-            </a:extLst>
-          </p:cNvPr>
-          <p:cNvCxnSpPr>
-            <a:cxnSpLocks/>
-          </p:cNvCxnSpPr>
-          <p:nvPr/>
-        </p:nvCxnSpPr>
-        <p:spPr>
-          <a:xfrm>
-            <a:off x="2475764" y="1048473"/>
-            <a:ext cx="2320684" cy="0"/>
-          </a:xfrm>
-          <a:prstGeom prst="straightConnector1">
-            <a:avLst/>
-          </a:prstGeom>
-          <a:ln w="63500">
-            <a:headEnd type="triangle"/>
-            <a:tailEnd type="none"/>
-          </a:ln>
-        </p:spPr>
-        <p:style>
-          <a:lnRef idx="3">
-            <a:schemeClr val="dk1"/>
-          </a:lnRef>
-          <a:fillRef idx="0">
-            <a:schemeClr val="dk1"/>
-          </a:fillRef>
-          <a:effectRef idx="2">
-            <a:schemeClr val="dk1"/>
-          </a:effectRef>
-          <a:fontRef idx="minor">
-            <a:schemeClr val="tx1"/>
-          </a:fontRef>
-        </p:style>
-      </p:cxnSp>
-      <p:sp>
-        <p:nvSpPr>
-          <p:cNvPr id="8" name="TextBox 7">
-            <a:extLst>
-              <a:ext uri="{FF2B5EF4-FFF2-40B4-BE49-F238E27FC236}">
-                <a16:creationId xmlns:a16="http://schemas.microsoft.com/office/drawing/2014/main" id="{423168B1-82C6-3745-8220-F394426F0CF0}"/>
-              </a:ext>
-            </a:extLst>
-          </p:cNvPr>
-          <p:cNvSpPr txBox="1"/>
-          <p:nvPr/>
-        </p:nvSpPr>
-        <p:spPr>
-          <a:xfrm>
-            <a:off x="2606617" y="1150595"/>
-            <a:ext cx="2058977" cy="369332"/>
-          </a:xfrm>
-          <a:prstGeom prst="rect">
-            <a:avLst/>
-          </a:prstGeom>
-          <a:noFill/>
-        </p:spPr>
-        <p:txBody>
-          <a:bodyPr wrap="square" rtlCol="0">
-            <a:spAutoFit/>
-          </a:bodyPr>
-          <a:lstStyle/>
-          <a:p>
-            <a:pPr algn="ctr"/>
-            <a:r>
-              <a:rPr lang="en-US" dirty="0" err="1"/>
-              <a:t>OperationOutcome</a:t>
-            </a:r>
-            <a:endParaRPr lang="en-US" dirty="0"/>
+              <a:t>POST Bundle(s)</a:t>
+            </a:r>
           </a:p>
         </p:txBody>
       </p:sp>

</xml_diff>